<commit_message>
Fix PowerPoint OOXML transition compatibility
</commit_message>
<xml_diff>
--- a/BaoCao_LearnSpace.pptx
+++ b/BaoCao_LearnSpace.pptx
@@ -5105,12 +5105,12 @@
       </p:sp>
     </p:spTree>
   </p:cSld>
+  <p:clrMapOvr>
+    <a:masterClrMapping/>
+  </p:clrMapOvr>
   <p:transition spd="med">
     <p:fade/>
   </p:transition>
-  <p:clrMapOvr>
-    <a:masterClrMapping/>
-  </p:clrMapOvr>
 </p:sld>
 </file>
 
@@ -6379,12 +6379,12 @@
       </p:sp>
     </p:spTree>
   </p:cSld>
+  <p:clrMapOvr>
+    <a:masterClrMapping/>
+  </p:clrMapOvr>
   <p:transition spd="med">
     <p:fade/>
   </p:transition>
-  <p:clrMapOvr>
-    <a:masterClrMapping/>
-  </p:clrMapOvr>
 </p:sld>
 </file>
 
@@ -7098,12 +7098,12 @@
       </p:sp>
     </p:spTree>
   </p:cSld>
+  <p:clrMapOvr>
+    <a:masterClrMapping/>
+  </p:clrMapOvr>
   <p:transition spd="med">
     <p:push dir="l"/>
   </p:transition>
-  <p:clrMapOvr>
-    <a:masterClrMapping/>
-  </p:clrMapOvr>
 </p:sld>
 </file>
 
@@ -8167,12 +8167,12 @@
       </p:sp>
     </p:spTree>
   </p:cSld>
+  <p:clrMapOvr>
+    <a:masterClrMapping/>
+  </p:clrMapOvr>
   <p:transition spd="med">
     <p:wipe dir="r"/>
   </p:transition>
-  <p:clrMapOvr>
-    <a:masterClrMapping/>
-  </p:clrMapOvr>
 </p:sld>
 </file>
 
@@ -8636,12 +8636,12 @@
       </p:sp>
     </p:spTree>
   </p:cSld>
+  <p:clrMapOvr>
+    <a:masterClrMapping/>
+  </p:clrMapOvr>
   <p:transition spd="med">
     <p:fade/>
   </p:transition>
-  <p:clrMapOvr>
-    <a:masterClrMapping/>
-  </p:clrMapOvr>
 </p:sld>
 </file>
 
@@ -10319,12 +10319,12 @@
       </p:sp>
     </p:spTree>
   </p:cSld>
+  <p:clrMapOvr>
+    <a:masterClrMapping/>
+  </p:clrMapOvr>
   <p:transition spd="med">
     <p:push dir="l"/>
   </p:transition>
-  <p:clrMapOvr>
-    <a:masterClrMapping/>
-  </p:clrMapOvr>
 </p:sld>
 </file>
 
@@ -11759,12 +11759,12 @@
       </p:sp>
     </p:spTree>
   </p:cSld>
+  <p:clrMapOvr>
+    <a:masterClrMapping/>
+  </p:clrMapOvr>
   <p:transition spd="med">
     <p:wipe dir="r"/>
   </p:transition>
-  <p:clrMapOvr>
-    <a:masterClrMapping/>
-  </p:clrMapOvr>
 </p:sld>
 </file>
 
@@ -13094,12 +13094,12 @@
       </p:sp>
     </p:spTree>
   </p:cSld>
+  <p:clrMapOvr>
+    <a:masterClrMapping/>
+  </p:clrMapOvr>
   <p:transition spd="med">
     <p:fade/>
   </p:transition>
-  <p:clrMapOvr>
-    <a:masterClrMapping/>
-  </p:clrMapOvr>
 </p:sld>
 </file>
 
@@ -13989,12 +13989,12 @@
       </p:sp>
     </p:spTree>
   </p:cSld>
+  <p:clrMapOvr>
+    <a:masterClrMapping/>
+  </p:clrMapOvr>
   <p:transition spd="med">
     <p:fade/>
   </p:transition>
-  <p:clrMapOvr>
-    <a:masterClrMapping/>
-  </p:clrMapOvr>
 </p:sld>
 </file>
 
@@ -15273,12 +15273,12 @@
       </p:sp>
     </p:spTree>
   </p:cSld>
+  <p:clrMapOvr>
+    <a:masterClrMapping/>
+  </p:clrMapOvr>
   <p:transition spd="med">
     <p:push dir="l"/>
   </p:transition>
-  <p:clrMapOvr>
-    <a:masterClrMapping/>
-  </p:clrMapOvr>
 </p:sld>
 </file>
 
@@ -16539,12 +16539,12 @@
       </p:sp>
     </p:spTree>
   </p:cSld>
+  <p:clrMapOvr>
+    <a:masterClrMapping/>
+  </p:clrMapOvr>
   <p:transition spd="med">
     <p:wipe dir="r"/>
   </p:transition>
-  <p:clrMapOvr>
-    <a:masterClrMapping/>
-  </p:clrMapOvr>
 </p:sld>
 </file>
 
@@ -18519,12 +18519,12 @@
       </p:sp>
     </p:spTree>
   </p:cSld>
+  <p:clrMapOvr>
+    <a:masterClrMapping/>
+  </p:clrMapOvr>
   <p:transition spd="med">
     <p:fade/>
   </p:transition>
-  <p:clrMapOvr>
-    <a:masterClrMapping/>
-  </p:clrMapOvr>
 </p:sld>
 </file>
 
@@ -20408,12 +20408,12 @@
       </p:sp>
     </p:spTree>
   </p:cSld>
+  <p:clrMapOvr>
+    <a:masterClrMapping/>
+  </p:clrMapOvr>
   <p:transition spd="med">
     <p:push dir="l"/>
   </p:transition>
-  <p:clrMapOvr>
-    <a:masterClrMapping/>
-  </p:clrMapOvr>
 </p:sld>
 </file>
 
@@ -21897,12 +21897,12 @@
       </p:sp>
     </p:spTree>
   </p:cSld>
+  <p:clrMapOvr>
+    <a:masterClrMapping/>
+  </p:clrMapOvr>
   <p:transition spd="med">
     <p:wipe dir="r"/>
   </p:transition>
-  <p:clrMapOvr>
-    <a:masterClrMapping/>
-  </p:clrMapOvr>
 </p:sld>
 </file>
 
@@ -22576,12 +22576,12 @@
       </p:sp>
     </p:spTree>
   </p:cSld>
+  <p:clrMapOvr>
+    <a:masterClrMapping/>
+  </p:clrMapOvr>
   <p:transition spd="med">
     <p:fade/>
   </p:transition>
-  <p:clrMapOvr>
-    <a:masterClrMapping/>
-  </p:clrMapOvr>
 </p:sld>
 </file>
 
@@ -24553,12 +24553,12 @@
       </p:sp>
     </p:spTree>
   </p:cSld>
+  <p:clrMapOvr>
+    <a:masterClrMapping/>
+  </p:clrMapOvr>
   <p:transition spd="med">
     <p:push dir="l"/>
   </p:transition>
-  <p:clrMapOvr>
-    <a:masterClrMapping/>
-  </p:clrMapOvr>
 </p:sld>
 </file>
 
@@ -25072,12 +25072,12 @@
       </p:sp>
     </p:spTree>
   </p:cSld>
+  <p:clrMapOvr>
+    <a:masterClrMapping/>
+  </p:clrMapOvr>
   <p:transition spd="med">
     <p:wipe dir="r"/>
   </p:transition>
-  <p:clrMapOvr>
-    <a:masterClrMapping/>
-  </p:clrMapOvr>
 </p:sld>
 </file>
 

</xml_diff>